<commit_message>
chore: organize worklog files and presentation assets
</commit_message>
<xml_diff>
--- a/reports/presentation/RAG_프로젝트_발표템플릿_SoftEditorial.pptx
+++ b/reports/presentation/RAG_프로젝트_발표템플릿_SoftEditorial.pptx
@@ -1531,7 +1531,7 @@
                 <a:ea typeface="Calibri" pitchFamily="34" charset="-122"/>
                 <a:cs typeface="Calibri" pitchFamily="34" charset="-120"/>
               </a:rPr>
-              <a:t>AI 중급 프로젝트 · RAG 시스템</a:t>
+              <a:t/>
             </a:r>
             <a:endParaRPr lang="en-US" sz="1400" dirty="0"/>
           </a:p>
@@ -1570,7 +1570,7 @@
                 <a:ea typeface="Cambria" pitchFamily="34" charset="-122"/>
                 <a:cs typeface="Cambria" pitchFamily="34" charset="-120"/>
               </a:rPr>
-              <a:t>[프로젝트 제목을 입력하세요]</a:t>
+              <a:t>AI 중급 프로젝트 · RAG 시스템</a:t>
             </a:r>
             <a:endParaRPr lang="en-US" sz="4400" dirty="0"/>
           </a:p>
@@ -1609,7 +1609,7 @@
                 <a:ea typeface="Calibri" pitchFamily="34" charset="-122"/>
                 <a:cs typeface="Calibri" pitchFamily="34" charset="-120"/>
               </a:rPr>
-              <a:t>[입찰/RFP 문서 기반 질의응답 RAG 시스템 — 한 줄 소개를 입력하세요]</a:t>
+              <a:t>입찰/RFP 문서 기반 질의응답 RAG 시스템</a:t>
             </a:r>
             <a:endParaRPr lang="en-US" sz="1600" dirty="0"/>
           </a:p>
@@ -1648,7 +1648,7 @@
                 <a:ea typeface="Calibri" pitchFamily="34" charset="-122"/>
                 <a:cs typeface="Calibri" pitchFamily="34" charset="-120"/>
               </a:rPr>
-              <a:t>[팀명]  ·  [팀원 이름]  ·  [발표일]</a:t>
+              <a:t>김효진  ·  2026.08.03</a:t>
             </a:r>
             <a:endParaRPr lang="en-US" sz="1300" dirty="0"/>
           </a:p>

</xml_diff>